<commit_message>
BD II y ARQ: clases 3 a 8 al estandar de terminado y justificacion de todas las opciones en los parciales
</commit_message>
<xml_diff>
--- a/Arquitectura de Sistemas Computacionales/Clases/Clase 14 - Parcial 3/Presentacion.pptx
+++ b/Arquitectura de Sistemas Computacionales/Clases/Clase 14 - Parcial 3/Presentacion.pptx
@@ -8,6 +8,7 @@
     <p:sldId id="256" r:id="rId7"/>
     <p:sldId id="257" r:id="rId8"/>
     <p:sldId id="258" r:id="rId9"/>
+    <p:sldId id="259" r:id="rId10"/>
   </p:sldIdLst>
   <p:sldSz cx="12191695" cy="6858000" type="screen4x3"/>
   <p:notesSz cx="6858000" cy="9144000"/>
@@ -3287,7 +3288,7 @@
                 </a:solidFill>
                 <a:latin typeface="Calibri"/>
               </a:rPr>
-              <a:t>Solo evaluación · sin tema de trabajo dirigido</a:t>
+              <a:t>Solo evaluación · sin tema ni taller dirigido</a:t>
             </a:r>
           </a:p>
         </p:txBody>
@@ -3326,7 +3327,7 @@
                 </a:solidFill>
                 <a:latin typeface="Calibri"/>
               </a:rPr>
-              <a:t>Hoy avanzamos el PI en:</a:t>
+              <a:t>Hoy es solo el parcial:</a:t>
             </a:r>
             <a:r>
               <a:rPr sz="1500" b="0" i="0">
@@ -3335,7 +3336,7 @@
                 </a:solidFill>
                 <a:latin typeface="Calibri"/>
               </a:rPr>
-              <a:t> Sin trabajo dirigido nuevo de PI (evaluación del corte)</a:t>
+              <a:t> no hay tema nuevo ni taller del PI.</a:t>
             </a:r>
           </a:p>
           <a:p>
@@ -3369,7 +3370,25 @@
                 </a:solidFill>
                 <a:latin typeface="Calibri"/>
               </a:rPr>
-              <a:t> · Teoría breve · Taller PI · cierre.</a:t>
+              <a:t> · sesión </a:t>
+            </a:r>
+            <a:r>
+              <a:rPr sz="1500" b="1" i="0">
+                <a:solidFill>
+                  <a:srgbClr val="333333"/>
+                </a:solidFill>
+                <a:latin typeface="Calibri"/>
+              </a:rPr>
+              <a:t>virtual síncrona</a:t>
+            </a:r>
+            <a:r>
+              <a:rPr sz="1500" b="0" i="0">
+                <a:solidFill>
+                  <a:srgbClr val="333333"/>
+                </a:solidFill>
+                <a:latin typeface="Calibri"/>
+              </a:rPr>
+              <a:t> por Google Meet.</a:t>
             </a:r>
           </a:p>
           <a:p>
@@ -3385,7 +3404,25 @@
                 </a:solidFill>
                 <a:latin typeface="Calibri"/>
               </a:rPr>
-              <a:t>Herramientas gratis + navegador · sin AWS/GCP/Oracle Cloud.</a:t>
+              <a:t>El enunciado se comparte al empezar · </a:t>
+            </a:r>
+            <a:r>
+              <a:rPr sz="1500" b="1" i="0">
+                <a:solidFill>
+                  <a:srgbClr val="333333"/>
+                </a:solidFill>
+                <a:latin typeface="Calibri"/>
+              </a:rPr>
+              <a:t>no</a:t>
+            </a:r>
+            <a:r>
+              <a:rPr sz="1500" b="0" i="0">
+                <a:solidFill>
+                  <a:srgbClr val="333333"/>
+                </a:solidFill>
+                <a:latin typeface="Calibri"/>
+              </a:rPr>
+              <a:t> se distribuye antes.</a:t>
             </a:r>
           </a:p>
         </p:txBody>
@@ -3434,6 +3471,423 @@
 </file>
 
 <file path=ppt/slides/slide2.xml><?xml version="1.0" encoding="utf-8"?>
+<p:sld xmlns:a="http://schemas.openxmlformats.org/drawingml/2006/main" xmlns:p="http://schemas.openxmlformats.org/presentationml/2006/main" xmlns:r="http://schemas.openxmlformats.org/officeDocument/2006/relationships">
+  <p:cSld>
+    <p:bg>
+      <p:bgPr>
+        <a:solidFill>
+          <a:srgbClr val="FFFFFF"/>
+        </a:solidFill>
+        <a:effectLst/>
+      </p:bgPr>
+    </p:bg>
+    <p:spTree>
+      <p:nvGrpSpPr>
+        <p:cNvPr id="1" name=""/>
+        <p:cNvGrpSpPr/>
+        <p:nvPr/>
+      </p:nvGrpSpPr>
+      <p:grpSpPr/>
+      <p:sp>
+        <p:nvSpPr>
+          <p:cNvPr id="2" name="Rectangle 1"/>
+          <p:cNvSpPr/>
+          <p:nvPr/>
+        </p:nvSpPr>
+        <p:spPr>
+          <a:xfrm>
+            <a:off x="0" y="0"/>
+            <a:ext cx="12191695" cy="1170432"/>
+          </a:xfrm>
+          <a:prstGeom prst="rect">
+            <a:avLst/>
+          </a:prstGeom>
+          <a:solidFill>
+            <a:srgbClr val="095292"/>
+          </a:solidFill>
+          <a:ln>
+            <a:noFill/>
+          </a:ln>
+        </p:spPr>
+        <p:style>
+          <a:lnRef idx="1">
+            <a:schemeClr val="accent1"/>
+          </a:lnRef>
+          <a:fillRef idx="3">
+            <a:schemeClr val="accent1"/>
+          </a:fillRef>
+          <a:effectRef idx="2">
+            <a:schemeClr val="accent1"/>
+          </a:effectRef>
+          <a:fontRef idx="minor">
+            <a:schemeClr val="lt1"/>
+          </a:fontRef>
+        </p:style>
+        <p:txBody>
+          <a:bodyPr rtlCol="0" anchor="ctr"/>
+          <a:lstStyle/>
+          <a:p>
+            <a:pPr algn="ctr"/>
+          </a:p>
+        </p:txBody>
+      </p:sp>
+      <p:sp>
+        <p:nvSpPr>
+          <p:cNvPr id="3" name="Rectangle 2"/>
+          <p:cNvSpPr/>
+          <p:nvPr/>
+        </p:nvSpPr>
+        <p:spPr>
+          <a:xfrm>
+            <a:off x="0" y="1170432"/>
+            <a:ext cx="12191695" cy="41148"/>
+          </a:xfrm>
+          <a:prstGeom prst="rect">
+            <a:avLst/>
+          </a:prstGeom>
+          <a:solidFill>
+            <a:srgbClr val="FFD000"/>
+          </a:solidFill>
+          <a:ln>
+            <a:noFill/>
+          </a:ln>
+        </p:spPr>
+        <p:style>
+          <a:lnRef idx="1">
+            <a:schemeClr val="accent1"/>
+          </a:lnRef>
+          <a:fillRef idx="3">
+            <a:schemeClr val="accent1"/>
+          </a:fillRef>
+          <a:effectRef idx="2">
+            <a:schemeClr val="accent1"/>
+          </a:effectRef>
+          <a:fontRef idx="minor">
+            <a:schemeClr val="lt1"/>
+          </a:fontRef>
+        </p:style>
+        <p:txBody>
+          <a:bodyPr rtlCol="0" anchor="ctr"/>
+          <a:lstStyle/>
+          <a:p>
+            <a:pPr algn="ctr"/>
+          </a:p>
+        </p:txBody>
+      </p:sp>
+      <p:sp>
+        <p:nvSpPr>
+          <p:cNvPr id="4" name="TextBox 3"/>
+          <p:cNvSpPr txBox="1"/>
+          <p:nvPr/>
+        </p:nvSpPr>
+        <p:spPr>
+          <a:xfrm>
+            <a:off x="457200" y="164592"/>
+            <a:ext cx="11277295" cy="384048"/>
+          </a:xfrm>
+          <a:prstGeom prst="rect">
+            <a:avLst/>
+          </a:prstGeom>
+          <a:noFill/>
+        </p:spPr>
+        <p:txBody>
+          <a:bodyPr wrap="square">
+            <a:spAutoFit/>
+          </a:bodyPr>
+          <a:lstStyle/>
+          <a:p>
+            <a:r>
+              <a:rPr sz="2600" b="1" i="0">
+                <a:solidFill>
+                  <a:srgbClr val="FFFFFF"/>
+                </a:solidFill>
+                <a:latin typeface="Calibri"/>
+              </a:rPr>
+              <a:t>Qué se evalúa hoy</a:t>
+            </a:r>
+          </a:p>
+        </p:txBody>
+      </p:sp>
+      <p:sp>
+        <p:nvSpPr>
+          <p:cNvPr id="5" name="TextBox 4"/>
+          <p:cNvSpPr txBox="1"/>
+          <p:nvPr/>
+        </p:nvSpPr>
+        <p:spPr>
+          <a:xfrm>
+            <a:off x="457200" y="566928"/>
+            <a:ext cx="11277295" cy="411480"/>
+          </a:xfrm>
+          <a:prstGeom prst="rect">
+            <a:avLst/>
+          </a:prstGeom>
+          <a:noFill/>
+        </p:spPr>
+        <p:txBody>
+          <a:bodyPr wrap="square">
+            <a:spAutoFit/>
+          </a:bodyPr>
+          <a:lstStyle/>
+          <a:p>
+            <a:r>
+              <a:rPr sz="1400" b="1" i="0">
+                <a:solidFill>
+                  <a:srgbClr val="B8D8EE"/>
+                </a:solidFill>
+                <a:latin typeface="Calibri"/>
+              </a:rPr>
+              <a:t>Solo</a:t>
+            </a:r>
+            <a:r>
+              <a:rPr sz="1400" b="0" i="0">
+                <a:solidFill>
+                  <a:srgbClr val="B8D8EE"/>
+                </a:solidFill>
+                <a:latin typeface="Calibri"/>
+              </a:rPr>
+              <a:t> Clase 11 · Clase 12 · Clase 13 — fuera de esa lista no hay nada</a:t>
+            </a:r>
+          </a:p>
+        </p:txBody>
+      </p:sp>
+      <p:sp>
+        <p:nvSpPr>
+          <p:cNvPr id="6" name="TextBox 5"/>
+          <p:cNvSpPr txBox="1"/>
+          <p:nvPr/>
+        </p:nvSpPr>
+        <p:spPr>
+          <a:xfrm>
+            <a:off x="457200" y="1380744"/>
+            <a:ext cx="11277295" cy="5020056"/>
+          </a:xfrm>
+          <a:prstGeom prst="rect">
+            <a:avLst/>
+          </a:prstGeom>
+          <a:noFill/>
+        </p:spPr>
+        <p:txBody>
+          <a:bodyPr wrap="square">
+            <a:spAutoFit/>
+          </a:bodyPr>
+          <a:lstStyle/>
+          <a:p>
+            <a:pPr>
+              <a:spcAft>
+                <a:spcPts val="800"/>
+              </a:spcAft>
+            </a:pPr>
+            <a:r>
+              <a:rPr sz="1600" b="0" i="0">
+                <a:solidFill>
+                  <a:srgbClr val="333333"/>
+                </a:solidFill>
+                <a:latin typeface="Calibri"/>
+              </a:rPr>
+              <a:t>–   </a:t>
+            </a:r>
+            <a:r>
+              <a:rPr sz="1600" b="1" i="0">
+                <a:solidFill>
+                  <a:srgbClr val="333333"/>
+                </a:solidFill>
+                <a:latin typeface="Calibri"/>
+              </a:rPr>
+              <a:t>A. Selección múltiple</a:t>
+            </a:r>
+            <a:r>
+              <a:rPr sz="1600" b="0" i="0">
+                <a:solidFill>
+                  <a:srgbClr val="333333"/>
+                </a:solidFill>
+                <a:latin typeface="Calibri"/>
+              </a:rPr>
+              <a:t> — 20 pts</a:t>
+            </a:r>
+          </a:p>
+          <a:p>
+            <a:pPr>
+              <a:spcAft>
+                <a:spcPts val="800"/>
+              </a:spcAft>
+            </a:pPr>
+            <a:r>
+              <a:rPr sz="1600" b="0" i="0">
+                <a:solidFill>
+                  <a:srgbClr val="333333"/>
+                </a:solidFill>
+                <a:latin typeface="Calibri"/>
+              </a:rPr>
+              <a:t>–   </a:t>
+            </a:r>
+            <a:r>
+              <a:rPr sz="1600" b="1" i="0">
+                <a:solidFill>
+                  <a:srgbClr val="333333"/>
+                </a:solidFill>
+                <a:latin typeface="Calibri"/>
+              </a:rPr>
+              <a:t>B. Emparejamiento</a:t>
+            </a:r>
+            <a:r>
+              <a:rPr sz="1600" b="0" i="0">
+                <a:solidFill>
+                  <a:srgbClr val="333333"/>
+                </a:solidFill>
+                <a:latin typeface="Calibri"/>
+              </a:rPr>
+              <a:t> — 20 pts</a:t>
+            </a:r>
+          </a:p>
+          <a:p>
+            <a:pPr>
+              <a:spcAft>
+                <a:spcPts val="800"/>
+              </a:spcAft>
+            </a:pPr>
+            <a:r>
+              <a:rPr sz="1600" b="0" i="0">
+                <a:solidFill>
+                  <a:srgbClr val="333333"/>
+                </a:solidFill>
+                <a:latin typeface="Calibri"/>
+              </a:rPr>
+              <a:t>–   </a:t>
+            </a:r>
+            <a:r>
+              <a:rPr sz="1600" b="1" i="0">
+                <a:solidFill>
+                  <a:srgbClr val="333333"/>
+                </a:solidFill>
+                <a:latin typeface="Calibri"/>
+              </a:rPr>
+              <a:t>C. Rendimiento y escalabilidad</a:t>
+            </a:r>
+            <a:r>
+              <a:rPr sz="1600" b="0" i="0">
+                <a:solidFill>
+                  <a:srgbClr val="333333"/>
+                </a:solidFill>
+                <a:latin typeface="Calibri"/>
+              </a:rPr>
+              <a:t> — 25 pts</a:t>
+            </a:r>
+          </a:p>
+          <a:p>
+            <a:pPr>
+              <a:spcAft>
+                <a:spcPts val="800"/>
+              </a:spcAft>
+            </a:pPr>
+            <a:r>
+              <a:rPr sz="1600" b="0" i="0">
+                <a:solidFill>
+                  <a:srgbClr val="333333"/>
+                </a:solidFill>
+                <a:latin typeface="Calibri"/>
+              </a:rPr>
+              <a:t>–   </a:t>
+            </a:r>
+            <a:r>
+              <a:rPr sz="1600" b="1" i="0">
+                <a:solidFill>
+                  <a:srgbClr val="333333"/>
+                </a:solidFill>
+                <a:latin typeface="Calibri"/>
+              </a:rPr>
+              <a:t>D. Caso de sustentación arquitectónica</a:t>
+            </a:r>
+            <a:r>
+              <a:rPr sz="1600" b="0" i="0">
+                <a:solidFill>
+                  <a:srgbClr val="333333"/>
+                </a:solidFill>
+                <a:latin typeface="Calibri"/>
+              </a:rPr>
+              <a:t> — 35 pts</a:t>
+            </a:r>
+          </a:p>
+          <a:p>
+            <a:pPr>
+              <a:spcAft>
+                <a:spcPts val="800"/>
+              </a:spcAft>
+            </a:pPr>
+            <a:r>
+              <a:rPr sz="1600" b="0" i="0">
+                <a:solidFill>
+                  <a:srgbClr val="333333"/>
+                </a:solidFill>
+                <a:latin typeface="Calibri"/>
+              </a:rPr>
+              <a:t>–   Total </a:t>
+            </a:r>
+            <a:r>
+              <a:rPr sz="1600" b="1" i="0">
+                <a:solidFill>
+                  <a:srgbClr val="333333"/>
+                </a:solidFill>
+                <a:latin typeface="Calibri"/>
+              </a:rPr>
+              <a:t>100 puntos</a:t>
+            </a:r>
+            <a:r>
+              <a:rPr sz="1600" b="0" i="0">
+                <a:solidFill>
+                  <a:srgbClr val="333333"/>
+                </a:solidFill>
+                <a:latin typeface="Calibri"/>
+              </a:rPr>
+              <a:t> · nota = puntos / 20 · este parcial pesa 15% del Corte 3 (40%).</a:t>
+            </a:r>
+          </a:p>
+        </p:txBody>
+      </p:sp>
+      <p:sp>
+        <p:nvSpPr>
+          <p:cNvPr id="7" name="TextBox 6"/>
+          <p:cNvSpPr txBox="1"/>
+          <p:nvPr/>
+        </p:nvSpPr>
+        <p:spPr>
+          <a:xfrm>
+            <a:off x="11185855" y="6473952"/>
+            <a:ext cx="640080" cy="274320"/>
+          </a:xfrm>
+          <a:prstGeom prst="rect">
+            <a:avLst/>
+          </a:prstGeom>
+          <a:noFill/>
+        </p:spPr>
+        <p:txBody>
+          <a:bodyPr wrap="square">
+            <a:spAutoFit/>
+          </a:bodyPr>
+          <a:lstStyle/>
+          <a:p>
+            <a:pPr algn="r"/>
+            <a:r>
+              <a:rPr sz="1100" b="0" i="0">
+                <a:solidFill>
+                  <a:srgbClr val="666666"/>
+                </a:solidFill>
+                <a:latin typeface="Calibri"/>
+              </a:rPr>
+              <a:t>2</a:t>
+            </a:r>
+          </a:p>
+        </p:txBody>
+      </p:sp>
+    </p:spTree>
+  </p:cSld>
+  <p:clrMapOvr>
+    <a:masterClrMapping/>
+  </p:clrMapOvr>
+</p:sld>
+</file>
+
+<file path=ppt/slides/slide3.xml><?xml version="1.0" encoding="utf-8"?>
 <p:sld xmlns:a="http://schemas.openxmlformats.org/drawingml/2006/main" xmlns:p="http://schemas.openxmlformats.org/presentationml/2006/main" xmlns:r="http://schemas.openxmlformats.org/officeDocument/2006/relationships">
   <p:cSld>
     <p:bg>
@@ -3566,7 +4020,7 @@
                 </a:solidFill>
                 <a:latin typeface="Calibri"/>
               </a:rPr>
-              <a:t>Indicaciones</a:t>
+              <a:t>Cómo se responde y cómo se entrega</a:t>
             </a:r>
           </a:p>
         </p:txBody>
@@ -3605,7 +4059,7 @@
                 </a:solidFill>
                 <a:latin typeface="Calibri"/>
               </a:rPr>
-              <a:t>–   Hoy es </a:t>
+              <a:t>–   Tiempo previsto </a:t>
             </a:r>
             <a:r>
               <a:rPr sz="1600" b="1" i="0">
@@ -3614,7 +4068,7 @@
                 </a:solidFill>
                 <a:latin typeface="Calibri"/>
               </a:rPr>
-              <a:t>solo Parcial</a:t>
+              <a:t>90–100 minutos</a:t>
             </a:r>
             <a:r>
               <a:rPr sz="1600" b="0" i="0">
@@ -3623,7 +4077,7 @@
                 </a:solidFill>
                 <a:latin typeface="Calibri"/>
               </a:rPr>
-              <a:t> (virtual síncrono por Meet).</a:t>
+              <a:t> dentro del bloque de 120.</a:t>
             </a:r>
           </a:p>
           <a:p>
@@ -3639,7 +4093,25 @@
                 </a:solidFill>
                 <a:latin typeface="Calibri"/>
               </a:rPr>
-              <a:t>–   No hay taller ni avance dirigido del PI en esta clase.</a:t>
+              <a:t>–   El envío </a:t>
+            </a:r>
+            <a:r>
+              <a:rPr sz="1600" b="1" i="0">
+                <a:solidFill>
+                  <a:srgbClr val="333333"/>
+                </a:solidFill>
+                <a:latin typeface="Calibri"/>
+              </a:rPr>
+              <a:t>cierra en el minuto 110</a:t>
+            </a:r>
+            <a:r>
+              <a:rPr sz="1600" b="0" i="0">
+                <a:solidFill>
+                  <a:srgbClr val="333333"/>
+                </a:solidFill>
+                <a:latin typeface="Calibri"/>
+              </a:rPr>
+              <a:t>: lo que llegue después no se recibe.</a:t>
             </a:r>
           </a:p>
           <a:p>
@@ -3655,7 +4127,7 @@
                 </a:solidFill>
                 <a:latin typeface="Calibri"/>
               </a:rPr>
-              <a:t>–   Material de evaluación en carpeta docente de Parciales (no se distribuye antes).</a:t>
+              <a:t>–   Canal de entrega: el que se anuncia ahora. Confirmo cada recibido por el chat.</a:t>
             </a:r>
           </a:p>
           <a:p>
@@ -3671,7 +4143,59 @@
                 </a:solidFill>
                 <a:latin typeface="Calibri"/>
               </a:rPr>
-              <a:t>–   La prep del PI / pitch quedó en la clase regular anterior.</a:t>
+              <a:t>–   Pregunta de </a:t>
+            </a:r>
+            <a:r>
+              <a:rPr sz="1600" b="1" i="0">
+                <a:solidFill>
+                  <a:srgbClr val="333333"/>
+                </a:solidFill>
+                <a:latin typeface="Calibri"/>
+              </a:rPr>
+              <a:t>forma</a:t>
+            </a:r>
+            <a:r>
+              <a:rPr sz="1600" b="0" i="0">
+                <a:solidFill>
+                  <a:srgbClr val="333333"/>
+                </a:solidFill>
+                <a:latin typeface="Calibri"/>
+              </a:rPr>
+              <a:t> sí (cuántas líneas, si pide tabla). De </a:t>
+            </a:r>
+            <a:r>
+              <a:rPr sz="1600" b="1" i="0">
+                <a:solidFill>
+                  <a:srgbClr val="333333"/>
+                </a:solidFill>
+                <a:latin typeface="Calibri"/>
+              </a:rPr>
+              <a:t>contenido</a:t>
+            </a:r>
+            <a:r>
+              <a:rPr sz="1600" b="0" i="0">
+                <a:solidFill>
+                  <a:srgbClr val="333333"/>
+                </a:solidFill>
+                <a:latin typeface="Calibri"/>
+              </a:rPr>
+              <a:t> no.</a:t>
+            </a:r>
+          </a:p>
+          <a:p>
+            <a:pPr>
+              <a:spcAft>
+                <a:spcPts val="800"/>
+              </a:spcAft>
+            </a:pPr>
+            <a:r>
+              <a:rPr sz="1600" b="0" i="0">
+                <a:solidFill>
+                  <a:srgbClr val="333333"/>
+                </a:solidFill>
+                <a:latin typeface="Calibri"/>
+              </a:rPr>
+              <a:t>–   Si se te cae el internet: sigue respondiendo y avisa por correo al volver.</a:t>
             </a:r>
           </a:p>
         </p:txBody>
@@ -3706,7 +4230,7 @@
                 </a:solidFill>
                 <a:latin typeface="Calibri"/>
               </a:rPr>
-              <a:t>2</a:t>
+              <a:t>3</a:t>
             </a:r>
           </a:p>
         </p:txBody>
@@ -3719,7 +4243,7 @@
 </p:sld>
 </file>
 
-<file path=ppt/slides/slide3.xml><?xml version="1.0" encoding="utf-8"?>
+<file path=ppt/slides/slide4.xml><?xml version="1.0" encoding="utf-8"?>
 <p:sld xmlns:a="http://schemas.openxmlformats.org/drawingml/2006/main" xmlns:p="http://schemas.openxmlformats.org/presentationml/2006/main" xmlns:r="http://schemas.openxmlformats.org/officeDocument/2006/relationships">
   <p:cSld>
     <p:bg>
@@ -3871,7 +4395,7 @@
                 </a:solidFill>
                 <a:latin typeface="Calibri"/>
               </a:rPr>
-              <a:t>Enfocados en la evaluación del corte</a:t>
+              <a:t>Hoy solo se evalúa el corte</a:t>
             </a:r>
           </a:p>
           <a:p>
@@ -3887,7 +4411,7 @@
                 </a:solidFill>
                 <a:latin typeface="Calibri"/>
               </a:rPr>
-              <a:t>PI CloudLite continúa en la siguiente clase regular/autónoma</a:t>
+              <a:t>Clase 15: sustentación del PI CloudLite, no hay tema nuevo</a:t>
             </a:r>
           </a:p>
         </p:txBody>

</xml_diff>